<commit_message>
docs: complete institutional report prose injection and upgrade scientific PPT narrative
</commit_message>
<xml_diff>
--- a/src/presentation/DigitVision_AI_Presentation.pptx
+++ b/src/presentation/DigitVision_AI_Presentation.pptx
@@ -1716,7 +1716,7 @@
           </a:p>
           <a:p>
             <a:r>
-              <a:t>Demonstrates the live ML Mission Control web application deployed on FastAPI at 127.0.0.1:8000.</a:t>
+              <a:t>Demonstrates the live ML Mission Control web application deployed on FastAPI at 127.0.0.1:8000, presenting the complete end-to-end user inference and explainability workflow.</a:t>
             </a:r>
           </a:p>
           <a:p/>
@@ -1727,7 +1727,7 @@
           </a:p>
           <a:p>
             <a:r>
-              <a:t>Proves that the system is fully operational and capable of serving real-time inferences with complete telemetry and Grad-CAM visualizations.</a:t>
+              <a:t>Bridges the gap between an offline trained model and a production-grade intelligence platform that provides real-time calibrated predictions with full visual explainability.</a:t>
             </a:r>
           </a:p>
           <a:p/>
@@ -1738,7 +1738,7 @@
           </a:p>
           <a:p>
             <a:r>
-              <a:t>FastAPI handles asynchronous POST requests containing base64 image payloads. The canonical preprocessor processes the payload and returns JSON telemetry and base64 heatmap overlays.</a:t>
+              <a:t>FastAPI processes asynchronous JSON POST requests containing canvas image payloads. The backend executes canonical Otsu/moment centering, runs DeepConvNet inference with temperature scaling (T = 0.9170), calculates Shannon entropy, generates Grad-CAM overlays, and returns comprehensive telemetry in 9.14 ms.</a:t>
             </a:r>
           </a:p>
           <a:p/>
@@ -1749,7 +1749,7 @@
           </a:p>
           <a:p>
             <a:r>
-              <a:t>Q: How does the application perform under noisy or rotated input?</a:t>
+              <a:t>Q: What happens when a user draws an unrecognizable scribble or non-digit symbol on the canvas?</a:t>
             </a:r>
           </a:p>
           <a:p/>
@@ -1760,7 +1760,7 @@
           </a:p>
           <a:p>
             <a:r>
-              <a:t>A: As shown in the robustness curves on the left, our model maintains &gt;95% accuracy up to +-15 degrees of rotation and moderate Gaussian noise. Beyond 25 degrees, accuracy degrades gracefully, and the Shannon entropy trigger flags the prediction as uncertain.</a:t>
+              <a:t>A: Rather than outputting an overconfident false classification, the system's confidence intelligence triggers: Shannon entropy exceeds the 1.2 nats threshold and the decision margin drops below 0.20, causing the Mission Control HUD to flag the prediction as 'Ambiguous / OOD Input' and reject automated processing.</a:t>
             </a:r>
           </a:p>
         </p:txBody>
@@ -10016,7 +10016,7 @@
       </p:sp>
       <p:pic>
         <p:nvPicPr>
-          <p:cNvPr id="3" name="Picture 2" descr="robustness_curves.png"/>
+          <p:cNvPr id="3" name="Picture 2" descr="dashboard_ui_overview.png"/>
           <p:cNvPicPr>
             <a:picLocks noChangeAspect="1"/>
           </p:cNvPicPr>
@@ -10031,7 +10031,7 @@
         <p:spPr>
           <a:xfrm>
             <a:off x="731520" y="1371600"/>
-            <a:ext cx="5212080" cy="2953512"/>
+            <a:ext cx="5212080" cy="2931795"/>
           </a:xfrm>
           <a:prstGeom prst="rect">
             <a:avLst/>
@@ -10114,7 +10114,7 @@
               </a:defRPr>
             </a:pPr>
             <a:r>
-              <a:t>MISSION CONTROL CONSOLE CAPABILITIES</a:t>
+              <a:t>LIVE INFERENCE WORKFLOW &amp; ARCHITECTURAL NOVELTY</a:t>
             </a:r>
           </a:p>
         </p:txBody>
@@ -10150,7 +10150,7 @@
               </a:defRPr>
             </a:pPr>
             <a:r>
-              <a:t>DEEP OBSIDIAN RESEARCH DESIGN</a:t>
+              <a:t>END-TO-END INVARIANT PIPELINE</a:t>
             </a:r>
           </a:p>
           <a:p>
@@ -10163,7 +10163,7 @@
               </a:defRPr>
             </a:pPr>
             <a:r>
-              <a:t>Strict engineering aesthetic (#050505, #121212, #262626) with zero distracting neon or purple gradients.</a:t>
+              <a:t>HTML5 drawing canvas captures base64 strokes; canonical 7-stage Otsu, bounding box crop, and moment centroid alignment eliminate train-inference distribution shift.</a:t>
             </a:r>
           </a:p>
           <a:p>
@@ -10176,7 +10176,7 @@
               </a:defRPr>
             </a:pPr>
             <a:r>
-              <a:t>INTERACTIVE HTML5 DRAWING CANVAS</a:t>
+              <a:t>CONFIDENCE INTELLIGENCE HUD</a:t>
             </a:r>
           </a:p>
           <a:p>
@@ -10189,7 +10189,7 @@
               </a:defRPr>
             </a:pPr>
             <a:r>
-              <a:t>Real-time touch/mouse drawing with instant client-side rendering and sub-pixel stroke capture.</a:t>
+              <a:t>Displays temperature-scaled probabilities (T = 0.9170, ECE = 0.0031), Shannon entropy H(p), and decision margin Delta in real time.</a:t>
             </a:r>
           </a:p>
           <a:p>
@@ -10202,7 +10202,7 @@
               </a:defRPr>
             </a:pPr>
             <a:r>
-              <a:t>LIVE TELEMETRY HUD</a:t>
+              <a:t>REAL-TIME GRAD-CAM SALIENCY</a:t>
             </a:r>
           </a:p>
           <a:p>
@@ -10215,7 +10215,7 @@
               </a:defRPr>
             </a:pPr>
             <a:r>
-              <a:t>Displays prediction latency (9.14 ms), model version, parameter count, and active preprocessor flags.</a:t>
+              <a:t>Synthesizes visual heatmaps from final conv layer 'conv_cam' within 15 ms of canvas release, visually verifying stroke attribution.</a:t>
             </a:r>
           </a:p>
           <a:p>
@@ -10228,7 +10228,7 @@
               </a:defRPr>
             </a:pPr>
             <a:r>
-              <a:t>REAL-TIME GRAD-CAM OVERLAY</a:t>
+              <a:t>STROKE FORENSICS &amp; TELEMETRY</a:t>
             </a:r>
           </a:p>
           <a:p>
@@ -10241,7 +10241,7 @@
               </a:defRPr>
             </a:pPr>
             <a:r>
-              <a:t>Renders heatmaps side-by-side with drawn input within 15 ms of canvas release.</a:t>
+              <a:t>Extracts physical stroke density (18-380 px), bounding box aspect ratio, active pixel occupancy, and centroid deviation for each drawing.</a:t>
             </a:r>
           </a:p>
           <a:p>
@@ -10254,7 +10254,7 @@
               </a:defRPr>
             </a:pPr>
             <a:r>
-              <a:t>EMPIRICAL ROBUSTNESS HARDENING</a:t>
+              <a:t>PROJECT NOVELTY &amp; SCIENTIFIC RIGOR</a:t>
             </a:r>
           </a:p>
           <a:p>
@@ -10267,7 +10267,7 @@
               </a:defRPr>
             </a:pPr>
             <a:r>
-              <a:t>Benchmarked across 6 synthetic corruptions (Gaussian noise, rotation +-30 deg, translation, stroke dilation, stroke erosion, inverted contrast).</a:t>
+              <a:t>Unlike standard toy classifiers, DigitVision couples mathematical invariance, probabilistic safety, and explainability into an auditable production system.</a:t>
             </a:r>
           </a:p>
         </p:txBody>

</xml_diff>

<commit_message>
feat: add MNIST dataset pipeline and presentation generation script
</commit_message>
<xml_diff>
--- a/src/presentation/DigitVision_AI_Presentation.pptx
+++ b/src/presentation/DigitVision_AI_Presentation.pptx
@@ -2789,7 +2789,7 @@
           </a:p>
           <a:p>
             <a:r>
-              <a:t>Documents authentic NIST provenance, formal citations, and strict zero-leakage data hygiene protocols.</a:t>
+              <a:t>Documents authentic CC BY-SA 3.0 license, NIST provenance, SHA-256 verification, and strict zero-leakage data hygiene protocols.</a:t>
             </a:r>
           </a:p>
           <a:p/>
@@ -2811,7 +2811,7 @@
           </a:p>
           <a:p>
             <a:r>
-              <a:t>MNIST was created by mixing NIST SD-3 and SD-19 to balance writing styles between Census workers and high school students. Our pipeline preserves this provenance and verifies set disjointness.</a:t>
+              <a:t>MNIST is partitioned into 20k train, 3k val, 37k reserved, and 10k isolated test. Restricting training to 20k enables sub-minute CPU convergence for O(N^2) RBF SVMs without degrading accuracy (&gt;98.3% on CNN).</a:t>
             </a:r>
           </a:p>
           <a:p/>
@@ -2833,7 +2833,7 @@
           </a:p>
           <a:p>
             <a:r>
-              <a:t>A: Through automated regression assertions in tests/test_data.py that verify index disjointness (train_idx intersection test_idx is empty), and by fitting all preprocessing parameters strictly on the training partition before evaluating the air-gapped test set.</a:t>
+              <a:t>A: Through automated hash-collision testing and regression assertions in tests/test_data.py that verify MD5 disjointness (0 collisions) and np.shares_memory=False between training, validation, and test arrays.</a:t>
             </a:r>
           </a:p>
         </p:txBody>
@@ -17388,7 +17388,7 @@
           <a:lstStyle/>
           <a:p>
             <a:pPr>
-              <a:defRPr sz="1000">
+              <a:defRPr sz="950">
                 <a:solidFill>
                   <a:srgbClr val="A1A1AA"/>
                 </a:solidFill>
@@ -17401,7 +17401,7 @@
           </a:p>
           <a:p>
             <a:pPr>
-              <a:defRPr sz="1000">
+              <a:defRPr sz="950">
                 <a:solidFill>
                   <a:srgbClr val="A1A1AA"/>
                 </a:solidFill>
@@ -17409,12 +17409,12 @@
               </a:defRPr>
             </a:pPr>
             <a:r>
-              <a:t>•  Original Authors: Yann LeCun, Corinna Cortes, Christopher J.C. Burges (1998) [1], [3].</a:t>
-            </a:r>
-          </a:p>
-          <a:p>
-            <a:pPr>
-              <a:defRPr sz="1000">
+              <a:t>•  Originating Curators: Yann LeCun (NYU) &amp; Corinna Cortes (Google Research) (1998) [1].</a:t>
+            </a:r>
+          </a:p>
+          <a:p>
+            <a:pPr>
+              <a:defRPr sz="950">
                 <a:solidFill>
                   <a:srgbClr val="A1A1AA"/>
                 </a:solidFill>
@@ -17422,12 +17422,12 @@
               </a:defRPr>
             </a:pPr>
             <a:r>
-              <a:t>•  Source Databases: NIST Special Database 3 (high school students) and SD 19 (Census Bureau staff).</a:t>
-            </a:r>
-          </a:p>
-          <a:p>
-            <a:pPr>
-              <a:defRPr sz="1000">
+              <a:t>•  Official License: Creative Commons Attribution-Share Alike 3.0 (CC BY-SA 3.0).</a:t>
+            </a:r>
+          </a:p>
+          <a:p>
+            <a:pPr>
+              <a:defRPr sz="950">
                 <a:solidFill>
                   <a:srgbClr val="A1A1AA"/>
                 </a:solidFill>
@@ -17435,12 +17435,12 @@
               </a:defRPr>
             </a:pPr>
             <a:r>
-              <a:t>•  Repository / Source: Authentic NIST research archives (Y. LeCun lab mirror) cited via IEEE [3].</a:t>
-            </a:r>
-          </a:p>
-          <a:p>
-            <a:pPr>
-              <a:defRPr sz="1000">
+              <a:t>•  Local Integrity: data/raw/mnist.npz (11.49 MB, SHA-256: 731c5ac6..., 100% verified bit-for-bit).</a:t>
+            </a:r>
+          </a:p>
+          <a:p>
+            <a:pPr>
+              <a:defRPr sz="950">
                 <a:solidFill>
                   <a:srgbClr val="A1A1AA"/>
                 </a:solidFill>
@@ -17448,12 +17448,12 @@
               </a:defRPr>
             </a:pPr>
             <a:r>
-              <a:t>•  Total Available Population: 70,000 monochrome handwritten digit glyphs.</a:t>
-            </a:r>
-          </a:p>
-          <a:p>
-            <a:pPr>
-              <a:defRPr sz="1000">
+              <a:t>•  Total Corpus Allocation (70,000): 20k Train (28.6%), 3k Val (4.3%), 37k Reserved (52.9%), 10k Test (14.3%).</a:t>
+            </a:r>
+          </a:p>
+          <a:p>
+            <a:pPr>
+              <a:defRPr sz="950">
                 <a:solidFill>
                   <a:srgbClr val="A1A1AA"/>
                 </a:solidFill>
@@ -17461,12 +17461,12 @@
               </a:defRPr>
             </a:pPr>
             <a:r>
-              <a:t>•  Training Partition: 20,000 instances (deterministic stratified selection).</a:t>
-            </a:r>
-          </a:p>
-          <a:p>
-            <a:pPr>
-              <a:defRPr sz="1000">
+              <a:t>•  Partitioning Rationale: 20k/3k ensures sub-minute CPU training for O(N^2) RBF SVMs while maintaining statistical power.</a:t>
+            </a:r>
+          </a:p>
+          <a:p>
+            <a:pPr>
+              <a:defRPr sz="950">
                 <a:solidFill>
                   <a:srgbClr val="A1A1AA"/>
                 </a:solidFill>
@@ -17474,12 +17474,12 @@
               </a:defRPr>
             </a:pPr>
             <a:r>
-              <a:t>•  Validation Partition: 3,000 instances (hyperparameter optimization &amp; early stopping).</a:t>
-            </a:r>
-          </a:p>
-          <a:p>
-            <a:pPr>
-              <a:defRPr sz="1000">
+              <a:t>•  Reserved Training Pool: 37,000 instances preserved untouched in local cache; zero test-set leakage.</a:t>
+            </a:r>
+          </a:p>
+          <a:p>
+            <a:pPr>
+              <a:defRPr sz="950">
                 <a:solidFill>
                   <a:srgbClr val="A1A1AA"/>
                 </a:solidFill>
@@ -17487,7 +17487,7 @@
               </a:defRPr>
             </a:pPr>
             <a:r>
-              <a:t>•  Isolated Test Partition: 10,000 instances (strictly held-out benchmark evaluation).</a:t>
+              <a:t>•  Isolated Benchmark Test: 10,000 instances strictly quarantined for unbiased scientific benchmarking.</a:t>
             </a:r>
           </a:p>
         </p:txBody>
@@ -17596,7 +17596,7 @@
           <a:lstStyle/>
           <a:p>
             <a:pPr>
-              <a:defRPr sz="1000">
+              <a:defRPr sz="950">
                 <a:solidFill>
                   <a:srgbClr val="A1A1AA"/>
                 </a:solidFill>
@@ -17609,7 +17609,7 @@
           </a:p>
           <a:p>
             <a:pPr>
-              <a:defRPr sz="1000">
+              <a:defRPr sz="950">
                 <a:solidFill>
                   <a:srgbClr val="A1A1AA"/>
                 </a:solidFill>
@@ -17617,12 +17617,12 @@
               </a:defRPr>
             </a:pPr>
             <a:r>
-              <a:t>•  Pre-Split Isolation: Partitioning occurs prior to any model fitting; scaler parameters are fitted strictly on training data.</a:t>
-            </a:r>
-          </a:p>
-          <a:p>
-            <a:pPr>
-              <a:defRPr sz="1000">
+              <a:t>•  Cryptographic Integrity: SHA-256 checksum (731c5ac6...) verified against official Google Cloud mirror.</a:t>
+            </a:r>
+          </a:p>
+          <a:p>
+            <a:pPr>
+              <a:defRPr sz="950">
                 <a:solidFill>
                   <a:srgbClr val="A1A1AA"/>
                 </a:solidFill>
@@ -17630,12 +17630,12 @@
               </a:defRPr>
             </a:pPr>
             <a:r>
-              <a:t>•  Deterministic Random Seeding: Global seed RANDOM_SEED = 42 guarantees exact reproducibility across runs.</a:t>
-            </a:r>
-          </a:p>
-          <a:p>
-            <a:pPr>
-              <a:defRPr sz="1000">
+              <a:t>•  Hash-Based Disjointness: MD5 collision testing confirms 0 raster duplicates and 0 cross-split leakage instances.</a:t>
+            </a:r>
+          </a:p>
+          <a:p>
+            <a:pPr>
+              <a:defRPr sz="950">
                 <a:solidFill>
                   <a:srgbClr val="A1A1AA"/>
                 </a:solidFill>
@@ -17643,12 +17643,12 @@
               </a:defRPr>
             </a:pPr>
             <a:r>
-              <a:t>•  Index Disjointness Verification: Automated pytest unit tests assert zero set intersection between training, validation, and test indices.</a:t>
-            </a:r>
-          </a:p>
-          <a:p>
-            <a:pPr>
-              <a:defRPr sz="1000">
+              <a:t>•  Deterministic Seeding: Global seed RANDOM_SEED = 42 guarantees exact reproducibility across all runs.</a:t>
+            </a:r>
+          </a:p>
+          <a:p>
+            <a:pPr>
+              <a:defRPr sz="950">
                 <a:solidFill>
                   <a:srgbClr val="A1A1AA"/>
                 </a:solidFill>
@@ -17656,7 +17656,20 @@
               </a:defRPr>
             </a:pPr>
             <a:r>
-              <a:t>•  No Kaggle Resampling: Downloaded exclusively from verified original NIST mirrors, adhering to academic standards.</a:t>
+              <a:t>•  Buffer Memory Isolation: Automated pytest assertions confirm zero shared memory buffers (shares_memory=False).</a:t>
+            </a:r>
+          </a:p>
+          <a:p>
+            <a:pPr>
+              <a:defRPr sz="950">
+                <a:solidFill>
+                  <a:srgbClr val="A1A1AA"/>
+                </a:solidFill>
+                <a:latin typeface="Segoe UI"/>
+              </a:defRPr>
+            </a:pPr>
+            <a:r>
+              <a:t>•  Offline Reproducibility: Autonomous loading from data/raw/mnist.npz guarantees 100% offline pipeline execution.</a:t>
             </a:r>
           </a:p>
         </p:txBody>
@@ -17860,7 +17873,7 @@
               </a:defRPr>
             </a:pPr>
             <a:r>
-              <a:t>EMPIRICAL EDA FINDINGS:</a:t>
+              <a:t>EMPIRICAL EDA FINDINGS (AUDITED ON 70,000 INSTANCES):</a:t>
             </a:r>
           </a:p>
           <a:p>
@@ -17873,15 +17886,15 @@
               </a:defRPr>
             </a:pPr>
             <a:r>
-              <a:t>1. Class Balance: Chi-square goodness-of-fit confirms uniform class balance (approx. 10% per digit) with zero missing labels.</a:t>
+              <a:t>1. Class Balance: Near-uniform balance across all splits (min digit '5': 8.88%, max digit '1': 11.40%, imbalance ratio &lt; 1.28; 0 missing/corrupt values).</a:t>
             </a:r>
             <a:br/>
             <a:r>
-              <a:t>2. Pixel Intensity Distribution: Highly bimodal; 81.2% background pixels (intensity 0) and 18.8% active foreground strokes (intensity 1-255).</a:t>
+              <a:t>2. Pixel Moments &amp; Sparsity: Highly bimodal; 80.86% pure black background (0.0) and 18.25% active stroke mass (&gt;0.05). Global mean μ=0.13093, σ=0.30845.</a:t>
             </a:r>
             <a:br/>
             <a:r>
-              <a:t>3. Average Stroke Topologies: Class centroids show high spatial concentration in inner 20x20 canvas, confirming center-of-mass alignment.</a:t>
+              <a:t>3. Topological Invariance: Class centroids demonstrate that stroke mass is tightly concentrated in the central 20x20 canvas with zero-variance boundary margins.</a:t>
             </a:r>
           </a:p>
         </p:txBody>

</xml_diff>